<commit_message>
Rewrite vehicle proposal deck with generic non-personalized copy
</commit_message>
<xml_diff>
--- a/assets/LLR_Knoepfler_Vehicle_Partnership_Proposal.pptx
+++ b/assets/LLR_Knoepfler_Vehicle_Partnership_Proposal.pptx
@@ -2392,7 +2392,7 @@
                 <a:ea typeface="Aptos" pitchFamily="34" charset="-122"/>
                 <a:cs typeface="Aptos" pitchFamily="34" charset="-120"/>
               </a:rPr>
-              <a:t>A tailored vehicle partnership proposal for {{DEALERSHIP}}</a:t>
+              <a:t>A tailored vehicle partnership proposal for your dealership</a:t>
             </a:r>
             <a:endParaRPr lang="en-US" sz="1800" dirty="0"/>
           </a:p>
@@ -4265,7 +4265,7 @@
                 <a:ea typeface="Aptos Display" pitchFamily="34" charset="-122"/>
                 <a:cs typeface="Aptos Display" pitchFamily="34" charset="-120"/>
               </a:rPr>
-              <a:t>{{DEALERSHIP}} receives a defined 12-month recognition + content package centered on the vehicle and the community impact it enables.</a:t>
+              <a:t>Your dealership receives a defined 12-month recognition + content package centered on the vehicle and the community impact it enables.</a:t>
             </a:r>
             <a:endParaRPr lang="en-US" sz="1800" dirty="0"/>
           </a:p>
@@ -5323,7 +5323,7 @@
                 <a:ea typeface="Aptos Display" pitchFamily="34" charset="-122"/>
                 <a:cs typeface="Aptos Display" pitchFamily="34" charset="-120"/>
               </a:rPr>
-              <a:t>Lost Limb Riders × {{DEALERSHIP}}</a:t>
+              <a:t>Lost Limb Riders × Your Dealership</a:t>
             </a:r>
             <a:endParaRPr lang="en-US" sz="1800" dirty="0"/>
           </a:p>
@@ -5619,7 +5619,7 @@
                 <a:ea typeface="Aptos" pitchFamily="34" charset="-122"/>
                 <a:cs typeface="Aptos" pitchFamily="34" charset="-120"/>
               </a:rPr>
-              <a:t>Meet with {{DEALERSHIP}} leadership to identify the right vehicle and partnership structure, then finalize the recognition plan and launch date.</a:t>
+              <a:t>Meet with your leadership team to identify the right vehicle and partnership structure, then finalize the recognition plan and launch date.</a:t>
             </a:r>
             <a:endParaRPr lang="en-US" sz="1200" dirty="0"/>
           </a:p>
@@ -6262,7 +6262,7 @@
                 <a:ea typeface="Aptos" pitchFamily="34" charset="-122"/>
                 <a:cs typeface="Aptos" pitchFamily="34" charset="-120"/>
               </a:rPr>
-              <a:t>{{DEALERSHIP}} is connected to a concrete outcome: helping an amputee-focused nonprofit reach people and build community.</a:t>
+              <a:t>Your dealership is connected to a concrete outcome: helping an amputee-focused nonprofit reach people and build community.</a:t>
             </a:r>
             <a:endParaRPr lang="en-US" sz="1200" dirty="0"/>
           </a:p>
@@ -6414,7 +6414,7 @@
                 <a:ea typeface="Aptos Display" pitchFamily="34" charset="-122"/>
                 <a:cs typeface="Aptos Display" pitchFamily="34" charset="-120"/>
               </a:rPr>
-              <a:t>WHY {{DEALERSHIP}}</a:t>
+              <a:t>WHY YOUR DEALERSHIP</a:t>
             </a:r>
             <a:endParaRPr lang="en-US" sz="1000" dirty="0"/>
           </a:p>
@@ -6455,7 +6455,7 @@
                 <a:ea typeface="Aptos Display" pitchFamily="34" charset="-122"/>
                 <a:cs typeface="Aptos Display" pitchFamily="34" charset="-120"/>
               </a:rPr>
-              <a:t>A partnership that fits your dealership’s local identity.</a:t>
+              <a:t>A partnership that fits your local identity.</a:t>
             </a:r>
             <a:endParaRPr lang="en-US" sz="3000" dirty="0"/>
           </a:p>
@@ -6496,7 +6496,7 @@
                 <a:ea typeface="Aptos" pitchFamily="34" charset="-122"/>
                 <a:cs typeface="Aptos" pitchFamily="34" charset="-120"/>
               </a:rPr>
-              <a:t>{{DEALERSHIP}} is a locally rooted dealership with deep community ties. [CUSTOMIZE: 1-2 sentences on ownership, history, community presence.]</a:t>
+              <a:t>Local dealerships are woven into the communities they serve—built on relationships, longevity, and showing up beyond the showroom.</a:t>
             </a:r>
             <a:endParaRPr lang="en-US" sz="1400" dirty="0"/>
           </a:p>
@@ -6796,7 +6796,7 @@
                 <a:ea typeface="Aptos" pitchFamily="34" charset="-122"/>
                 <a:cs typeface="Aptos" pitchFamily="34" charset="-120"/>
               </a:rPr>
-              <a:t>[CUSTOMIZE: cite a recent community event, sponsorship, or local initiative by {{DEALERSHIP}}.]</a:t>
+              <a:t>Dealerships that already sponsor events, youth sports, and local causes know the value of visible community support. This partnership extends that instinct into sustained, everyday visibility.</a:t>
             </a:r>
             <a:endParaRPr lang="en-US" sz="1200" dirty="0"/>
           </a:p>
@@ -6837,7 +6837,7 @@
                 <a:ea typeface="Aptos" pitchFamily="34" charset="-122"/>
                 <a:cs typeface="Aptos" pitchFamily="34" charset="-120"/>
               </a:rPr>
-              <a:t>Source context: [CUSTOMIZE: dealership site / local news citation.]</a:t>
+              <a:t>Community-facing partnerships align naturally with dealerships that emphasize local roots and customer relationships.</a:t>
             </a:r>
             <a:endParaRPr lang="en-US" sz="900" dirty="0"/>
           </a:p>
@@ -7030,7 +7030,7 @@
                 <a:ea typeface="Aptos Display" pitchFamily="34" charset="-122"/>
                 <a:cs typeface="Aptos Display" pitchFamily="34" charset="-120"/>
               </a:rPr>
-              <a:t>A dependable SUV, crossover, truck or comparable vehicle selected with the dealership.</a:t>
+              <a:t>A dependable SUV, crossover, truck or comparable vehicle selected together.</a:t>
             </a:r>
             <a:endParaRPr lang="en-US" sz="1900" dirty="0"/>
           </a:p>
@@ -7276,7 +7276,7 @@
                 <a:ea typeface="Aptos" pitchFamily="34" charset="-122"/>
                 <a:cs typeface="Aptos" pitchFamily="34" charset="-120"/>
               </a:rPr>
-              <a:t>A vehicle {{DEALERSHIP}} is comfortable associating with its name and the partnership.</a:t>
+              <a:t>A vehicle you are comfortable associating with your name and the partnership.</a:t>
             </a:r>
             <a:endParaRPr lang="en-US" sz="1600" dirty="0"/>
           </a:p>
@@ -7576,7 +7576,7 @@
                 <a:ea typeface="Aptos Display" pitchFamily="34" charset="-122"/>
                 <a:cs typeface="Aptos Display" pitchFamily="34" charset="-120"/>
               </a:rPr>
-              <a:t>What {{DEALERSHIP}} receives.</a:t>
+              <a:t>What your dealership receives.</a:t>
             </a:r>
             <a:endParaRPr lang="en-US" sz="3000" dirty="0"/>
           </a:p>
@@ -10594,7 +10594,7 @@
                 <a:ea typeface="Aptos" pitchFamily="34" charset="-122"/>
                 <a:cs typeface="Aptos" pitchFamily="34" charset="-120"/>
               </a:rPr>
-              <a:t>National benchmark—not a claim about {{DEALERSHIP}}’s internal budget.</a:t>
+              <a:t>National benchmark—not a claim about any individual dealership’s budget.</a:t>
             </a:r>
             <a:endParaRPr lang="en-US" sz="1400" dirty="0"/>
           </a:p>
@@ -11298,7 +11298,7 @@
                 <a:ea typeface="Aptos" pitchFamily="34" charset="-122"/>
                 <a:cs typeface="Aptos" pitchFamily="34" charset="-120"/>
               </a:rPr>
-              <a:t>The partnership gives the public a concrete example of {{DEALERSHIP}} supporting an amputee-focused nonprofit—not merely a claim in an ad.</a:t>
+              <a:t>The partnership gives the public a concrete example of your dealership supporting an amputee-focused nonprofit—not merely a claim in an ad.</a:t>
             </a:r>
             <a:endParaRPr lang="en-US" sz="1200" dirty="0"/>
           </a:p>

</xml_diff>

<commit_message>
Audit deck/email claims: verify NADA stats, point sponsors to mission.html
</commit_message>
<xml_diff>
--- a/assets/LLR_Knoepfler_Vehicle_Partnership_Proposal.pptx
+++ b/assets/LLR_Knoepfler_Vehicle_Partnership_Proposal.pptx
@@ -5113,7 +5113,7 @@
                 <a:ea typeface="Aptos Display" pitchFamily="34" charset="-122"/>
                 <a:cs typeface="Aptos Display" pitchFamily="34" charset="-120"/>
               </a:rPr>
-              <a:t>Founder/CEO: John Thompson  •  general_llr@outlook.com  •  lostlimbriders.org</a:t>
+              <a:t>Founder/CEO: John Thompson  •  general_llr@outlook.com  •  lostlimbriders.org/mission.html</a:t>
             </a:r>
             <a:endParaRPr lang="en-US" sz="1300" dirty="0"/>
           </a:p>
@@ -5469,7 +5469,7 @@
                 <a:ea typeface="Aptos" pitchFamily="34" charset="-122"/>
                 <a:cs typeface="Aptos" pitchFamily="34" charset="-120"/>
               </a:rPr>
-              <a:t>lostlimbriders.org</a:t>
+              <a:t>lostlimbriders.org/mission.html</a:t>
             </a:r>
             <a:endParaRPr lang="en-US" sz="1400" dirty="0"/>
           </a:p>

</xml_diff>

<commit_message>
Brand all three decks with LLR logo; add logo guidance to email template
</commit_message>
<xml_diff>
--- a/assets/LLR_Knoepfler_Vehicle_Partnership_Proposal.pptx
+++ b/assets/LLR_Knoepfler_Vehicle_Partnership_Proposal.pptx
@@ -2721,6 +2721,30 @@
           </a:p>
         </p:txBody>
       </p:sp>
+      <p:pic>
+        <p:nvPicPr>
+          <p:cNvPr id="26" name="Picture 25" descr="logo-nobg.png"/>
+          <p:cNvPicPr>
+            <a:picLocks noChangeAspect="1"/>
+          </p:cNvPicPr>
+          <p:nvPr/>
+        </p:nvPicPr>
+        <p:blipFill>
+          <a:blip r:embed="rId3"/>
+          <a:stretch>
+            <a:fillRect/>
+          </a:stretch>
+        </p:blipFill>
+        <p:spPr>
+          <a:xfrm>
+            <a:off x="365760" y="274320"/>
+            <a:ext cx="1005840" cy="1005840"/>
+          </a:xfrm>
+          <a:prstGeom prst="rect">
+            <a:avLst/>
+          </a:prstGeom>
+        </p:spPr>
+      </p:pic>
     </p:spTree>
   </p:cSld>
   <p:clrMapOvr>
@@ -3568,6 +3592,30 @@
           </a:p>
         </p:txBody>
       </p:sp>
+      <p:pic>
+        <p:nvPicPr>
+          <p:cNvPr id="26" name="Picture 25" descr="logo-nobg.png"/>
+          <p:cNvPicPr>
+            <a:picLocks noChangeAspect="1"/>
+          </p:cNvPicPr>
+          <p:nvPr/>
+        </p:nvPicPr>
+        <p:blipFill>
+          <a:blip r:embed="rId3"/>
+          <a:stretch>
+            <a:fillRect/>
+          </a:stretch>
+        </p:blipFill>
+        <p:spPr>
+          <a:xfrm>
+            <a:off x="11414760" y="6217920"/>
+            <a:ext cx="502920" cy="502920"/>
+          </a:xfrm>
+          <a:prstGeom prst="rect">
+            <a:avLst/>
+          </a:prstGeom>
+        </p:spPr>
+      </p:pic>
     </p:spTree>
   </p:cSld>
   <p:clrMapOvr>
@@ -4016,6 +4064,30 @@
           </a:p>
         </p:txBody>
       </p:sp>
+      <p:pic>
+        <p:nvPicPr>
+          <p:cNvPr id="26" name="Picture 25" descr="logo-nobg.png"/>
+          <p:cNvPicPr>
+            <a:picLocks noChangeAspect="1"/>
+          </p:cNvPicPr>
+          <p:nvPr/>
+        </p:nvPicPr>
+        <p:blipFill>
+          <a:blip r:embed="rId3"/>
+          <a:stretch>
+            <a:fillRect/>
+          </a:stretch>
+        </p:blipFill>
+        <p:spPr>
+          <a:xfrm>
+            <a:off x="11414760" y="6217920"/>
+            <a:ext cx="502920" cy="502920"/>
+          </a:xfrm>
+          <a:prstGeom prst="rect">
+            <a:avLst/>
+          </a:prstGeom>
+        </p:spPr>
+      </p:pic>
     </p:spTree>
   </p:cSld>
   <p:clrMapOvr>
@@ -4603,6 +4675,30 @@
           </a:p>
         </p:txBody>
       </p:sp>
+      <p:pic>
+        <p:nvPicPr>
+          <p:cNvPr id="26" name="Picture 25" descr="logo-nobg.png"/>
+          <p:cNvPicPr>
+            <a:picLocks noChangeAspect="1"/>
+          </p:cNvPicPr>
+          <p:nvPr/>
+        </p:nvPicPr>
+        <p:blipFill>
+          <a:blip r:embed="rId3"/>
+          <a:stretch>
+            <a:fillRect/>
+          </a:stretch>
+        </p:blipFill>
+        <p:spPr>
+          <a:xfrm>
+            <a:off x="11414760" y="6217920"/>
+            <a:ext cx="502920" cy="502920"/>
+          </a:xfrm>
+          <a:prstGeom prst="rect">
+            <a:avLst/>
+          </a:prstGeom>
+        </p:spPr>
+      </p:pic>
     </p:spTree>
   </p:cSld>
   <p:clrMapOvr>
@@ -5164,6 +5260,30 @@
           </a:p>
         </p:txBody>
       </p:sp>
+      <p:pic>
+        <p:nvPicPr>
+          <p:cNvPr id="26" name="Picture 25" descr="logo-nobg.png"/>
+          <p:cNvPicPr>
+            <a:picLocks noChangeAspect="1"/>
+          </p:cNvPicPr>
+          <p:nvPr/>
+        </p:nvPicPr>
+        <p:blipFill>
+          <a:blip r:embed="rId3"/>
+          <a:stretch>
+            <a:fillRect/>
+          </a:stretch>
+        </p:blipFill>
+        <p:spPr>
+          <a:xfrm>
+            <a:off x="11003280" y="274320"/>
+            <a:ext cx="914400" cy="914400"/>
+          </a:xfrm>
+          <a:prstGeom prst="rect">
+            <a:avLst/>
+          </a:prstGeom>
+        </p:spPr>
+      </p:pic>
     </p:spTree>
   </p:cSld>
   <p:clrMapOvr>
@@ -5670,6 +5790,30 @@
           </a:p>
         </p:txBody>
       </p:sp>
+      <p:pic>
+        <p:nvPicPr>
+          <p:cNvPr id="26" name="Picture 25" descr="logo-nobg.png"/>
+          <p:cNvPicPr>
+            <a:picLocks noChangeAspect="1"/>
+          </p:cNvPicPr>
+          <p:nvPr/>
+        </p:nvPicPr>
+        <p:blipFill>
+          <a:blip r:embed="rId3"/>
+          <a:stretch>
+            <a:fillRect/>
+          </a:stretch>
+        </p:blipFill>
+        <p:spPr>
+          <a:xfrm>
+            <a:off x="5547360" y="320040"/>
+            <a:ext cx="1097280" cy="1097280"/>
+          </a:xfrm>
+          <a:prstGeom prst="rect">
+            <a:avLst/>
+          </a:prstGeom>
+        </p:spPr>
+      </p:pic>
     </p:spTree>
   </p:cSld>
   <p:clrMapOvr>
@@ -6354,6 +6498,30 @@
           </a:p>
         </p:txBody>
       </p:sp>
+      <p:pic>
+        <p:nvPicPr>
+          <p:cNvPr id="26" name="Picture 25" descr="logo-nobg.png"/>
+          <p:cNvPicPr>
+            <a:picLocks noChangeAspect="1"/>
+          </p:cNvPicPr>
+          <p:nvPr/>
+        </p:nvPicPr>
+        <p:blipFill>
+          <a:blip r:embed="rId3"/>
+          <a:stretch>
+            <a:fillRect/>
+          </a:stretch>
+        </p:blipFill>
+        <p:spPr>
+          <a:xfrm>
+            <a:off x="11414760" y="6217920"/>
+            <a:ext cx="502920" cy="502920"/>
+          </a:xfrm>
+          <a:prstGeom prst="rect">
+            <a:avLst/>
+          </a:prstGeom>
+        </p:spPr>
+      </p:pic>
     </p:spTree>
   </p:cSld>
   <p:clrMapOvr>
@@ -6888,6 +7056,30 @@
           </a:p>
         </p:txBody>
       </p:sp>
+      <p:pic>
+        <p:nvPicPr>
+          <p:cNvPr id="26" name="Picture 25" descr="logo-nobg.png"/>
+          <p:cNvPicPr>
+            <a:picLocks noChangeAspect="1"/>
+          </p:cNvPicPr>
+          <p:nvPr/>
+        </p:nvPicPr>
+        <p:blipFill>
+          <a:blip r:embed="rId3"/>
+          <a:stretch>
+            <a:fillRect/>
+          </a:stretch>
+        </p:blipFill>
+        <p:spPr>
+          <a:xfrm>
+            <a:off x="11414760" y="6217920"/>
+            <a:ext cx="502920" cy="502920"/>
+          </a:xfrm>
+          <a:prstGeom prst="rect">
+            <a:avLst/>
+          </a:prstGeom>
+        </p:spPr>
+      </p:pic>
     </p:spTree>
   </p:cSld>
   <p:clrMapOvr>
@@ -7475,6 +7667,30 @@
           </a:p>
         </p:txBody>
       </p:sp>
+      <p:pic>
+        <p:nvPicPr>
+          <p:cNvPr id="26" name="Picture 25" descr="logo-nobg.png"/>
+          <p:cNvPicPr>
+            <a:picLocks noChangeAspect="1"/>
+          </p:cNvPicPr>
+          <p:nvPr/>
+        </p:nvPicPr>
+        <p:blipFill>
+          <a:blip r:embed="rId3"/>
+          <a:stretch>
+            <a:fillRect/>
+          </a:stretch>
+        </p:blipFill>
+        <p:spPr>
+          <a:xfrm>
+            <a:off x="11414760" y="6217920"/>
+            <a:ext cx="502920" cy="502920"/>
+          </a:xfrm>
+          <a:prstGeom prst="rect">
+            <a:avLst/>
+          </a:prstGeom>
+        </p:spPr>
+      </p:pic>
     </p:spTree>
   </p:cSld>
   <p:clrMapOvr>
@@ -8322,6 +8538,30 @@
           </a:p>
         </p:txBody>
       </p:sp>
+      <p:pic>
+        <p:nvPicPr>
+          <p:cNvPr id="26" name="Picture 25" descr="logo-nobg.png"/>
+          <p:cNvPicPr>
+            <a:picLocks noChangeAspect="1"/>
+          </p:cNvPicPr>
+          <p:nvPr/>
+        </p:nvPicPr>
+        <p:blipFill>
+          <a:blip r:embed="rId3"/>
+          <a:stretch>
+            <a:fillRect/>
+          </a:stretch>
+        </p:blipFill>
+        <p:spPr>
+          <a:xfrm>
+            <a:off x="11414760" y="6217920"/>
+            <a:ext cx="502920" cy="502920"/>
+          </a:xfrm>
+          <a:prstGeom prst="rect">
+            <a:avLst/>
+          </a:prstGeom>
+        </p:spPr>
+      </p:pic>
     </p:spTree>
   </p:cSld>
   <p:clrMapOvr>
@@ -9230,6 +9470,30 @@
           </a:p>
         </p:txBody>
       </p:sp>
+      <p:pic>
+        <p:nvPicPr>
+          <p:cNvPr id="26" name="Picture 25" descr="logo-nobg.png"/>
+          <p:cNvPicPr>
+            <a:picLocks noChangeAspect="1"/>
+          </p:cNvPicPr>
+          <p:nvPr/>
+        </p:nvPicPr>
+        <p:blipFill>
+          <a:blip r:embed="rId3"/>
+          <a:stretch>
+            <a:fillRect/>
+          </a:stretch>
+        </p:blipFill>
+        <p:spPr>
+          <a:xfrm>
+            <a:off x="11414760" y="6217920"/>
+            <a:ext cx="502920" cy="502920"/>
+          </a:xfrm>
+          <a:prstGeom prst="rect">
+            <a:avLst/>
+          </a:prstGeom>
+        </p:spPr>
+      </p:pic>
     </p:spTree>
   </p:cSld>
   <p:clrMapOvr>
@@ -10452,6 +10716,30 @@
           </a:p>
         </p:txBody>
       </p:sp>
+      <p:pic>
+        <p:nvPicPr>
+          <p:cNvPr id="34" name="Picture 33" descr="logo-nobg.png"/>
+          <p:cNvPicPr>
+            <a:picLocks noChangeAspect="1"/>
+          </p:cNvPicPr>
+          <p:nvPr/>
+        </p:nvPicPr>
+        <p:blipFill>
+          <a:blip r:embed="rId3"/>
+          <a:stretch>
+            <a:fillRect/>
+          </a:stretch>
+        </p:blipFill>
+        <p:spPr>
+          <a:xfrm>
+            <a:off x="11414760" y="6217920"/>
+            <a:ext cx="502920" cy="502920"/>
+          </a:xfrm>
+          <a:prstGeom prst="rect">
+            <a:avLst/>
+          </a:prstGeom>
+        </p:spPr>
+      </p:pic>
     </p:spTree>
   </p:cSld>
   <p:clrMapOvr>
@@ -11047,6 +11335,30 @@
           </a:p>
         </p:txBody>
       </p:sp>
+      <p:pic>
+        <p:nvPicPr>
+          <p:cNvPr id="26" name="Picture 25" descr="logo-nobg.png"/>
+          <p:cNvPicPr>
+            <a:picLocks noChangeAspect="1"/>
+          </p:cNvPicPr>
+          <p:nvPr/>
+        </p:nvPicPr>
+        <p:blipFill>
+          <a:blip r:embed="rId3"/>
+          <a:stretch>
+            <a:fillRect/>
+          </a:stretch>
+        </p:blipFill>
+        <p:spPr>
+          <a:xfrm>
+            <a:off x="11414760" y="6217920"/>
+            <a:ext cx="502920" cy="502920"/>
+          </a:xfrm>
+          <a:prstGeom prst="rect">
+            <a:avLst/>
+          </a:prstGeom>
+        </p:spPr>
+      </p:pic>
     </p:spTree>
   </p:cSld>
   <p:clrMapOvr>
@@ -11649,6 +11961,30 @@
           </a:p>
         </p:txBody>
       </p:sp>
+      <p:pic>
+        <p:nvPicPr>
+          <p:cNvPr id="26" name="Picture 25" descr="logo-nobg.png"/>
+          <p:cNvPicPr>
+            <a:picLocks noChangeAspect="1"/>
+          </p:cNvPicPr>
+          <p:nvPr/>
+        </p:nvPicPr>
+        <p:blipFill>
+          <a:blip r:embed="rId3"/>
+          <a:stretch>
+            <a:fillRect/>
+          </a:stretch>
+        </p:blipFill>
+        <p:spPr>
+          <a:xfrm>
+            <a:off x="11414760" y="6217920"/>
+            <a:ext cx="502920" cy="502920"/>
+          </a:xfrm>
+          <a:prstGeom prst="rect">
+            <a:avLst/>
+          </a:prstGeom>
+        </p:spPr>
+      </p:pic>
     </p:spTree>
   </p:cSld>
   <p:clrMapOvr>

</xml_diff>